<commit_message>
update through lecture 6
</commit_message>
<xml_diff>
--- a/Lecture_Slides/PH 123 Lecture 03.pptx
+++ b/Lecture_Slides/PH 123 Lecture 03.pptx
@@ -158,7 +158,7 @@
 <file path=ppt/revisionInfo.xml><?xml version="1.0" encoding="utf-8"?>
 <p1510:revInfo xmlns:a="http://schemas.openxmlformats.org/drawingml/2006/main" xmlns:r="http://schemas.openxmlformats.org/officeDocument/2006/relationships" xmlns:p1510="http://schemas.microsoft.com/office/powerpoint/2015/10/main">
   <p1510:revLst>
-    <p1510:client id="{8FABBC37-5D60-4E81-B6F6-D086133F9481}" v="1" dt="2026-08-26T18:18:10.013"/>
+    <p1510:client id="{BB78BA21-BF34-43F3-BBFD-87163F5B96CE}" v="29" dt="2026-09-15T19:10:21.359"/>
   </p1510:revLst>
 </p1510:revInfo>
 </file>
@@ -168,10 +168,102 @@
   <pc:docChgLst>
     <pc:chgData name="Todd Lines" userId="afaf7c3a-e8aa-4568-882a-02ad8f9e19b0" providerId="ADAL" clId="{5FF5AC1B-ABA9-43D7-A1E3-2D92732CD6E2}"/>
     <pc:docChg chg="custSel addSld delSld modSld sldOrd">
-      <pc:chgData name="Todd Lines" userId="afaf7c3a-e8aa-4568-882a-02ad8f9e19b0" providerId="ADAL" clId="{5FF5AC1B-ABA9-43D7-A1E3-2D92732CD6E2}" dt="2026-08-26T18:19:58.459" v="27" actId="47"/>
+      <pc:chgData name="Todd Lines" userId="afaf7c3a-e8aa-4568-882a-02ad8f9e19b0" providerId="ADAL" clId="{5FF5AC1B-ABA9-43D7-A1E3-2D92732CD6E2}" dt="2026-09-15T19:11:54.336" v="553" actId="21"/>
       <pc:docMkLst>
         <pc:docMk/>
       </pc:docMkLst>
+      <pc:sldChg chg="addSp delSp modSp mod">
+        <pc:chgData name="Todd Lines" userId="afaf7c3a-e8aa-4568-882a-02ad8f9e19b0" providerId="ADAL" clId="{5FF5AC1B-ABA9-43D7-A1E3-2D92732CD6E2}" dt="2026-09-15T16:52:22.164" v="488" actId="21"/>
+        <pc:sldMkLst>
+          <pc:docMk/>
+          <pc:sldMk cId="0" sldId="366"/>
+        </pc:sldMkLst>
+        <pc:picChg chg="add del mod">
+          <ac:chgData name="Todd Lines" userId="afaf7c3a-e8aa-4568-882a-02ad8f9e19b0" providerId="ADAL" clId="{5FF5AC1B-ABA9-43D7-A1E3-2D92732CD6E2}" dt="2026-09-15T16:52:22.164" v="488" actId="21"/>
+          <ac:picMkLst>
+            <pc:docMk/>
+            <pc:sldMk cId="0" sldId="366"/>
+            <ac:picMk id="4" creationId="{C37D8F53-07BE-EAA0-3599-70FE04E7BC47}"/>
+          </ac:picMkLst>
+        </pc:picChg>
+      </pc:sldChg>
+      <pc:sldChg chg="addSp delSp modSp mod">
+        <pc:chgData name="Todd Lines" userId="afaf7c3a-e8aa-4568-882a-02ad8f9e19b0" providerId="ADAL" clId="{5FF5AC1B-ABA9-43D7-A1E3-2D92732CD6E2}" dt="2026-09-15T18:43:44.898" v="504" actId="21"/>
+        <pc:sldMkLst>
+          <pc:docMk/>
+          <pc:sldMk cId="0" sldId="377"/>
+        </pc:sldMkLst>
+        <pc:spChg chg="del mod">
+          <ac:chgData name="Todd Lines" userId="afaf7c3a-e8aa-4568-882a-02ad8f9e19b0" providerId="ADAL" clId="{5FF5AC1B-ABA9-43D7-A1E3-2D92732CD6E2}" dt="2026-09-15T18:43:22.777" v="501" actId="478"/>
+          <ac:spMkLst>
+            <pc:docMk/>
+            <pc:sldMk cId="0" sldId="377"/>
+            <ac:spMk id="14344" creationId="{00000000-0000-0000-0000-000000000000}"/>
+          </ac:spMkLst>
+        </pc:spChg>
+        <pc:picChg chg="add del">
+          <ac:chgData name="Todd Lines" userId="afaf7c3a-e8aa-4568-882a-02ad8f9e19b0" providerId="ADAL" clId="{5FF5AC1B-ABA9-43D7-A1E3-2D92732CD6E2}" dt="2026-09-15T18:43:09.385" v="498" actId="478"/>
+          <ac:picMkLst>
+            <pc:docMk/>
+            <pc:sldMk cId="0" sldId="377"/>
+            <ac:picMk id="3" creationId="{CBA6C5C7-CAC2-DBBB-48EE-9BF619F8ECBD}"/>
+          </ac:picMkLst>
+        </pc:picChg>
+        <pc:picChg chg="add del mod">
+          <ac:chgData name="Todd Lines" userId="afaf7c3a-e8aa-4568-882a-02ad8f9e19b0" providerId="ADAL" clId="{5FF5AC1B-ABA9-43D7-A1E3-2D92732CD6E2}" dt="2026-09-15T18:43:44.898" v="504" actId="21"/>
+          <ac:picMkLst>
+            <pc:docMk/>
+            <pc:sldMk cId="0" sldId="377"/>
+            <ac:picMk id="5" creationId="{F4681FE1-49CD-DD46-C422-1C77CD996D1F}"/>
+          </ac:picMkLst>
+        </pc:picChg>
+      </pc:sldChg>
+      <pc:sldChg chg="addSp delSp modSp mod">
+        <pc:chgData name="Todd Lines" userId="afaf7c3a-e8aa-4568-882a-02ad8f9e19b0" providerId="ADAL" clId="{5FF5AC1B-ABA9-43D7-A1E3-2D92732CD6E2}" dt="2026-09-15T18:46:58.643" v="518" actId="21"/>
+        <pc:sldMkLst>
+          <pc:docMk/>
+          <pc:sldMk cId="0" sldId="378"/>
+        </pc:sldMkLst>
+        <pc:picChg chg="add del mod">
+          <ac:chgData name="Todd Lines" userId="afaf7c3a-e8aa-4568-882a-02ad8f9e19b0" providerId="ADAL" clId="{5FF5AC1B-ABA9-43D7-A1E3-2D92732CD6E2}" dt="2026-09-15T18:44:01.435" v="507" actId="21"/>
+          <ac:picMkLst>
+            <pc:docMk/>
+            <pc:sldMk cId="0" sldId="378"/>
+            <ac:picMk id="3" creationId="{F540DC40-521A-6E73-2F57-BEFD2C6416A0}"/>
+          </ac:picMkLst>
+        </pc:picChg>
+        <pc:picChg chg="add del mod">
+          <ac:chgData name="Todd Lines" userId="afaf7c3a-e8aa-4568-882a-02ad8f9e19b0" providerId="ADAL" clId="{5FF5AC1B-ABA9-43D7-A1E3-2D92732CD6E2}" dt="2026-09-15T18:46:58.643" v="518" actId="21"/>
+          <ac:picMkLst>
+            <pc:docMk/>
+            <pc:sldMk cId="0" sldId="378"/>
+            <ac:picMk id="5" creationId="{B0A3EF4A-3347-ACD4-D8DB-609D115CA2DC}"/>
+          </ac:picMkLst>
+        </pc:picChg>
+      </pc:sldChg>
+      <pc:sldChg chg="addSp delSp modSp mod">
+        <pc:chgData name="Todd Lines" userId="afaf7c3a-e8aa-4568-882a-02ad8f9e19b0" providerId="ADAL" clId="{5FF5AC1B-ABA9-43D7-A1E3-2D92732CD6E2}" dt="2026-09-15T18:46:45.375" v="515" actId="21"/>
+        <pc:sldMkLst>
+          <pc:docMk/>
+          <pc:sldMk cId="0" sldId="379"/>
+        </pc:sldMkLst>
+        <pc:picChg chg="add del mod">
+          <ac:chgData name="Todd Lines" userId="afaf7c3a-e8aa-4568-882a-02ad8f9e19b0" providerId="ADAL" clId="{5FF5AC1B-ABA9-43D7-A1E3-2D92732CD6E2}" dt="2026-09-15T18:44:47.343" v="510" actId="21"/>
+          <ac:picMkLst>
+            <pc:docMk/>
+            <pc:sldMk cId="0" sldId="379"/>
+            <ac:picMk id="3" creationId="{CB8E01C8-F348-F7AD-BE81-07E60B14CBC1}"/>
+          </ac:picMkLst>
+        </pc:picChg>
+        <pc:picChg chg="add del mod">
+          <ac:chgData name="Todd Lines" userId="afaf7c3a-e8aa-4568-882a-02ad8f9e19b0" providerId="ADAL" clId="{5FF5AC1B-ABA9-43D7-A1E3-2D92732CD6E2}" dt="2026-09-15T18:46:45.375" v="515" actId="21"/>
+          <ac:picMkLst>
+            <pc:docMk/>
+            <pc:sldMk cId="0" sldId="379"/>
+            <ac:picMk id="5" creationId="{1B9D9A31-5915-942D-0C5A-61CCCD074ECC}"/>
+          </ac:picMkLst>
+        </pc:picChg>
+      </pc:sldChg>
       <pc:sldChg chg="ord">
         <pc:chgData name="Todd Lines" userId="afaf7c3a-e8aa-4568-882a-02ad8f9e19b0" providerId="ADAL" clId="{5FF5AC1B-ABA9-43D7-A1E3-2D92732CD6E2}" dt="2026-08-26T18:18:50.274" v="5"/>
         <pc:sldMkLst>
@@ -179,96 +271,137 @@
           <pc:sldMk cId="0" sldId="380"/>
         </pc:sldMkLst>
       </pc:sldChg>
-      <pc:sldChg chg="del">
-        <pc:chgData name="Todd Lines" userId="afaf7c3a-e8aa-4568-882a-02ad8f9e19b0" providerId="ADAL" clId="{5FF5AC1B-ABA9-43D7-A1E3-2D92732CD6E2}" dt="2026-08-26T18:19:58.459" v="27" actId="47"/>
+      <pc:sldChg chg="addSp modSp mod">
+        <pc:chgData name="Todd Lines" userId="afaf7c3a-e8aa-4568-882a-02ad8f9e19b0" providerId="ADAL" clId="{5FF5AC1B-ABA9-43D7-A1E3-2D92732CD6E2}" dt="2026-09-15T16:38:54.625" v="485" actId="20577"/>
         <pc:sldMkLst>
           <pc:docMk/>
-          <pc:sldMk cId="0" sldId="381"/>
+          <pc:sldMk cId="2400374094" sldId="402"/>
         </pc:sldMkLst>
+        <pc:spChg chg="add mod">
+          <ac:chgData name="Todd Lines" userId="afaf7c3a-e8aa-4568-882a-02ad8f9e19b0" providerId="ADAL" clId="{5FF5AC1B-ABA9-43D7-A1E3-2D92732CD6E2}" dt="2026-09-15T16:34:41.002" v="62" actId="1076"/>
+          <ac:spMkLst>
+            <pc:docMk/>
+            <pc:sldMk cId="2400374094" sldId="402"/>
+            <ac:spMk id="2" creationId="{68B2C6A7-B546-F75E-6AF8-97EA99858679}"/>
+          </ac:spMkLst>
+        </pc:spChg>
+        <pc:spChg chg="add mod">
+          <ac:chgData name="Todd Lines" userId="afaf7c3a-e8aa-4568-882a-02ad8f9e19b0" providerId="ADAL" clId="{5FF5AC1B-ABA9-43D7-A1E3-2D92732CD6E2}" dt="2026-09-15T16:38:37.888" v="469" actId="20577"/>
+          <ac:spMkLst>
+            <pc:docMk/>
+            <pc:sldMk cId="2400374094" sldId="402"/>
+            <ac:spMk id="16" creationId="{352720E6-3973-B8E8-0B50-AA434E120C57}"/>
+          </ac:spMkLst>
+        </pc:spChg>
+        <pc:spChg chg="add mod">
+          <ac:chgData name="Todd Lines" userId="afaf7c3a-e8aa-4568-882a-02ad8f9e19b0" providerId="ADAL" clId="{5FF5AC1B-ABA9-43D7-A1E3-2D92732CD6E2}" dt="2026-09-15T16:38:54.625" v="485" actId="20577"/>
+          <ac:spMkLst>
+            <pc:docMk/>
+            <pc:sldMk cId="2400374094" sldId="402"/>
+            <ac:spMk id="21" creationId="{1A7E0BC6-3682-A6B5-FD35-D7F4AB9BB1BB}"/>
+          </ac:spMkLst>
+        </pc:spChg>
+        <pc:spChg chg="mod">
+          <ac:chgData name="Todd Lines" userId="afaf7c3a-e8aa-4568-882a-02ad8f9e19b0" providerId="ADAL" clId="{5FF5AC1B-ABA9-43D7-A1E3-2D92732CD6E2}" dt="2026-09-15T16:38:08.645" v="450" actId="27636"/>
+          <ac:spMkLst>
+            <pc:docMk/>
+            <pc:sldMk cId="2400374094" sldId="402"/>
+            <ac:spMk id="27652" creationId="{00000000-0000-0000-0000-000000000000}"/>
+          </ac:spMkLst>
+        </pc:spChg>
+        <pc:cxnChg chg="add mod">
+          <ac:chgData name="Todd Lines" userId="afaf7c3a-e8aa-4568-882a-02ad8f9e19b0" providerId="ADAL" clId="{5FF5AC1B-ABA9-43D7-A1E3-2D92732CD6E2}" dt="2026-09-15T16:34:37.608" v="61" actId="693"/>
+          <ac:cxnSpMkLst>
+            <pc:docMk/>
+            <pc:sldMk cId="2400374094" sldId="402"/>
+            <ac:cxnSpMk id="6" creationId="{576C3C52-2B8E-31C2-F156-A26981F96AD7}"/>
+          </ac:cxnSpMkLst>
+        </pc:cxnChg>
+        <pc:cxnChg chg="add mod">
+          <ac:chgData name="Todd Lines" userId="afaf7c3a-e8aa-4568-882a-02ad8f9e19b0" providerId="ADAL" clId="{5FF5AC1B-ABA9-43D7-A1E3-2D92732CD6E2}" dt="2026-09-15T16:38:27.712" v="455" actId="14100"/>
+          <ac:cxnSpMkLst>
+            <pc:docMk/>
+            <pc:sldMk cId="2400374094" sldId="402"/>
+            <ac:cxnSpMk id="12" creationId="{73DBAD94-36FF-722D-7DD0-982C30701053}"/>
+          </ac:cxnSpMkLst>
+        </pc:cxnChg>
+        <pc:cxnChg chg="add mod">
+          <ac:chgData name="Todd Lines" userId="afaf7c3a-e8aa-4568-882a-02ad8f9e19b0" providerId="ADAL" clId="{5FF5AC1B-ABA9-43D7-A1E3-2D92732CD6E2}" dt="2026-09-15T16:38:47.305" v="473" actId="14100"/>
+          <ac:cxnSpMkLst>
+            <pc:docMk/>
+            <pc:sldMk cId="2400374094" sldId="402"/>
+            <ac:cxnSpMk id="17" creationId="{9D31261C-6FE1-9DFD-C51B-FC887E0FD185}"/>
+          </ac:cxnSpMkLst>
+        </pc:cxnChg>
       </pc:sldChg>
-      <pc:sldChg chg="del">
-        <pc:chgData name="Todd Lines" userId="afaf7c3a-e8aa-4568-882a-02ad8f9e19b0" providerId="ADAL" clId="{5FF5AC1B-ABA9-43D7-A1E3-2D92732CD6E2}" dt="2026-08-26T18:19:58.459" v="27" actId="47"/>
+      <pc:sldChg chg="addSp delSp modSp mod">
+        <pc:chgData name="Todd Lines" userId="afaf7c3a-e8aa-4568-882a-02ad8f9e19b0" providerId="ADAL" clId="{5FF5AC1B-ABA9-43D7-A1E3-2D92732CD6E2}" dt="2026-09-15T18:42:33.428" v="496" actId="21"/>
         <pc:sldMkLst>
           <pc:docMk/>
-          <pc:sldMk cId="0" sldId="385"/>
+          <pc:sldMk cId="2146591160" sldId="415"/>
         </pc:sldMkLst>
+        <pc:picChg chg="add del mod">
+          <ac:chgData name="Todd Lines" userId="afaf7c3a-e8aa-4568-882a-02ad8f9e19b0" providerId="ADAL" clId="{5FF5AC1B-ABA9-43D7-A1E3-2D92732CD6E2}" dt="2026-09-15T18:42:02.787" v="491" actId="21"/>
+          <ac:picMkLst>
+            <pc:docMk/>
+            <pc:sldMk cId="2146591160" sldId="415"/>
+            <ac:picMk id="3" creationId="{8971B1E8-A62D-BE27-A26C-D9CB71149E5F}"/>
+          </ac:picMkLst>
+        </pc:picChg>
+        <pc:picChg chg="add del">
+          <ac:chgData name="Todd Lines" userId="afaf7c3a-e8aa-4568-882a-02ad8f9e19b0" providerId="ADAL" clId="{5FF5AC1B-ABA9-43D7-A1E3-2D92732CD6E2}" dt="2026-09-15T18:42:21.003" v="493" actId="478"/>
+          <ac:picMkLst>
+            <pc:docMk/>
+            <pc:sldMk cId="2146591160" sldId="415"/>
+            <ac:picMk id="5" creationId="{255FB83B-FF4E-6314-18F2-CC9E4068B053}"/>
+          </ac:picMkLst>
+        </pc:picChg>
+        <pc:picChg chg="add del mod">
+          <ac:chgData name="Todd Lines" userId="afaf7c3a-e8aa-4568-882a-02ad8f9e19b0" providerId="ADAL" clId="{5FF5AC1B-ABA9-43D7-A1E3-2D92732CD6E2}" dt="2026-09-15T18:42:33.428" v="496" actId="21"/>
+          <ac:picMkLst>
+            <pc:docMk/>
+            <pc:sldMk cId="2146591160" sldId="415"/>
+            <ac:picMk id="8" creationId="{C48F5070-B6B7-330A-7533-399FC2B8929E}"/>
+          </ac:picMkLst>
+        </pc:picChg>
       </pc:sldChg>
-      <pc:sldChg chg="del">
-        <pc:chgData name="Todd Lines" userId="afaf7c3a-e8aa-4568-882a-02ad8f9e19b0" providerId="ADAL" clId="{5FF5AC1B-ABA9-43D7-A1E3-2D92732CD6E2}" dt="2026-08-26T18:19:58.459" v="27" actId="47"/>
-        <pc:sldMkLst>
-          <pc:docMk/>
-          <pc:sldMk cId="0" sldId="386"/>
-        </pc:sldMkLst>
-      </pc:sldChg>
-      <pc:sldChg chg="del">
-        <pc:chgData name="Todd Lines" userId="afaf7c3a-e8aa-4568-882a-02ad8f9e19b0" providerId="ADAL" clId="{5FF5AC1B-ABA9-43D7-A1E3-2D92732CD6E2}" dt="2026-08-26T18:19:58.459" v="27" actId="47"/>
-        <pc:sldMkLst>
-          <pc:docMk/>
-          <pc:sldMk cId="0" sldId="387"/>
-        </pc:sldMkLst>
-      </pc:sldChg>
-      <pc:sldChg chg="del">
-        <pc:chgData name="Todd Lines" userId="afaf7c3a-e8aa-4568-882a-02ad8f9e19b0" providerId="ADAL" clId="{5FF5AC1B-ABA9-43D7-A1E3-2D92732CD6E2}" dt="2026-08-26T18:19:58.459" v="27" actId="47"/>
-        <pc:sldMkLst>
-          <pc:docMk/>
-          <pc:sldMk cId="0" sldId="388"/>
-        </pc:sldMkLst>
-      </pc:sldChg>
-      <pc:sldChg chg="del">
-        <pc:chgData name="Todd Lines" userId="afaf7c3a-e8aa-4568-882a-02ad8f9e19b0" providerId="ADAL" clId="{5FF5AC1B-ABA9-43D7-A1E3-2D92732CD6E2}" dt="2026-08-26T18:19:58.459" v="27" actId="47"/>
-        <pc:sldMkLst>
-          <pc:docMk/>
-          <pc:sldMk cId="0" sldId="389"/>
-        </pc:sldMkLst>
-      </pc:sldChg>
-      <pc:sldChg chg="del">
-        <pc:chgData name="Todd Lines" userId="afaf7c3a-e8aa-4568-882a-02ad8f9e19b0" providerId="ADAL" clId="{5FF5AC1B-ABA9-43D7-A1E3-2D92732CD6E2}" dt="2026-08-26T18:19:58.459" v="27" actId="47"/>
-        <pc:sldMkLst>
-          <pc:docMk/>
-          <pc:sldMk cId="0" sldId="390"/>
-        </pc:sldMkLst>
-      </pc:sldChg>
-      <pc:sldChg chg="del">
-        <pc:chgData name="Todd Lines" userId="afaf7c3a-e8aa-4568-882a-02ad8f9e19b0" providerId="ADAL" clId="{5FF5AC1B-ABA9-43D7-A1E3-2D92732CD6E2}" dt="2026-08-26T18:19:58.459" v="27" actId="47"/>
-        <pc:sldMkLst>
-          <pc:docMk/>
-          <pc:sldMk cId="0" sldId="391"/>
-        </pc:sldMkLst>
-      </pc:sldChg>
-      <pc:sldChg chg="del">
-        <pc:chgData name="Todd Lines" userId="afaf7c3a-e8aa-4568-882a-02ad8f9e19b0" providerId="ADAL" clId="{5FF5AC1B-ABA9-43D7-A1E3-2D92732CD6E2}" dt="2026-08-26T18:19:58.459" v="27" actId="47"/>
-        <pc:sldMkLst>
-          <pc:docMk/>
-          <pc:sldMk cId="775210015" sldId="393"/>
-        </pc:sldMkLst>
-      </pc:sldChg>
-      <pc:sldChg chg="del">
-        <pc:chgData name="Todd Lines" userId="afaf7c3a-e8aa-4568-882a-02ad8f9e19b0" providerId="ADAL" clId="{5FF5AC1B-ABA9-43D7-A1E3-2D92732CD6E2}" dt="2026-08-26T18:19:58.459" v="27" actId="47"/>
-        <pc:sldMkLst>
-          <pc:docMk/>
-          <pc:sldMk cId="3934662764" sldId="394"/>
-        </pc:sldMkLst>
-      </pc:sldChg>
-      <pc:sldChg chg="add del">
-        <pc:chgData name="Todd Lines" userId="afaf7c3a-e8aa-4568-882a-02ad8f9e19b0" providerId="ADAL" clId="{5FF5AC1B-ABA9-43D7-A1E3-2D92732CD6E2}" dt="2026-08-26T18:18:58.690" v="6" actId="47"/>
-        <pc:sldMkLst>
-          <pc:docMk/>
-          <pc:sldMk cId="1986014694" sldId="399"/>
-        </pc:sldMkLst>
-      </pc:sldChg>
-      <pc:sldChg chg="add">
-        <pc:chgData name="Todd Lines" userId="afaf7c3a-e8aa-4568-882a-02ad8f9e19b0" providerId="ADAL" clId="{5FF5AC1B-ABA9-43D7-A1E3-2D92732CD6E2}" dt="2026-08-26T18:18:10.013" v="0"/>
+      <pc:sldChg chg="addSp delSp modSp add mod">
+        <pc:chgData name="Todd Lines" userId="afaf7c3a-e8aa-4568-882a-02ad8f9e19b0" providerId="ADAL" clId="{5FF5AC1B-ABA9-43D7-A1E3-2D92732CD6E2}" dt="2026-09-15T18:50:48.470" v="523" actId="21"/>
         <pc:sldMkLst>
           <pc:docMk/>
           <pc:sldMk cId="3570093930" sldId="416"/>
         </pc:sldMkLst>
+        <pc:picChg chg="add del">
+          <ac:chgData name="Todd Lines" userId="afaf7c3a-e8aa-4568-882a-02ad8f9e19b0" providerId="ADAL" clId="{5FF5AC1B-ABA9-43D7-A1E3-2D92732CD6E2}" dt="2026-09-15T18:50:36.397" v="520" actId="478"/>
+          <ac:picMkLst>
+            <pc:docMk/>
+            <pc:sldMk cId="3570093930" sldId="416"/>
+            <ac:picMk id="3" creationId="{8A93E415-0E4A-4A73-FC78-FD0F7D67B0DB}"/>
+          </ac:picMkLst>
+        </pc:picChg>
+        <pc:picChg chg="add del mod">
+          <ac:chgData name="Todd Lines" userId="afaf7c3a-e8aa-4568-882a-02ad8f9e19b0" providerId="ADAL" clId="{5FF5AC1B-ABA9-43D7-A1E3-2D92732CD6E2}" dt="2026-09-15T18:50:48.470" v="523" actId="21"/>
+          <ac:picMkLst>
+            <pc:docMk/>
+            <pc:sldMk cId="3570093930" sldId="416"/>
+            <ac:picMk id="5" creationId="{76533E3D-0980-A0AE-8F9C-591B00DE6F82}"/>
+          </ac:picMkLst>
+        </pc:picChg>
       </pc:sldChg>
-      <pc:sldChg chg="add">
-        <pc:chgData name="Todd Lines" userId="afaf7c3a-e8aa-4568-882a-02ad8f9e19b0" providerId="ADAL" clId="{5FF5AC1B-ABA9-43D7-A1E3-2D92732CD6E2}" dt="2026-08-26T18:18:10.013" v="0"/>
+      <pc:sldChg chg="addSp delSp modSp add mod">
+        <pc:chgData name="Todd Lines" userId="afaf7c3a-e8aa-4568-882a-02ad8f9e19b0" providerId="ADAL" clId="{5FF5AC1B-ABA9-43D7-A1E3-2D92732CD6E2}" dt="2026-09-15T19:11:54.336" v="553" actId="21"/>
         <pc:sldMkLst>
           <pc:docMk/>
           <pc:sldMk cId="3797345959" sldId="417"/>
         </pc:sldMkLst>
+        <pc:picChg chg="add del mod">
+          <ac:chgData name="Todd Lines" userId="afaf7c3a-e8aa-4568-882a-02ad8f9e19b0" providerId="ADAL" clId="{5FF5AC1B-ABA9-43D7-A1E3-2D92732CD6E2}" dt="2026-09-15T19:11:54.336" v="553" actId="21"/>
+          <ac:picMkLst>
+            <pc:docMk/>
+            <pc:sldMk cId="3797345959" sldId="417"/>
+            <ac:picMk id="3" creationId="{D30D5815-07E7-B719-EBD4-B28D1BBBF42A}"/>
+          </ac:picMkLst>
+        </pc:picChg>
       </pc:sldChg>
       <pc:sldChg chg="add">
         <pc:chgData name="Todd Lines" userId="afaf7c3a-e8aa-4568-882a-02ad8f9e19b0" providerId="ADAL" clId="{5FF5AC1B-ABA9-43D7-A1E3-2D92732CD6E2}" dt="2026-08-26T18:18:10.013" v="0"/>
@@ -277,19 +410,59 @@
           <pc:sldMk cId="0" sldId="418"/>
         </pc:sldMkLst>
       </pc:sldChg>
-      <pc:sldChg chg="add">
-        <pc:chgData name="Todd Lines" userId="afaf7c3a-e8aa-4568-882a-02ad8f9e19b0" providerId="ADAL" clId="{5FF5AC1B-ABA9-43D7-A1E3-2D92732CD6E2}" dt="2026-08-26T18:18:10.013" v="0"/>
+      <pc:sldChg chg="modSp add mod">
+        <pc:chgData name="Todd Lines" userId="afaf7c3a-e8aa-4568-882a-02ad8f9e19b0" providerId="ADAL" clId="{5FF5AC1B-ABA9-43D7-A1E3-2D92732CD6E2}" dt="2026-09-15T19:10:48.775" v="550" actId="1076"/>
         <pc:sldMkLst>
           <pc:docMk/>
           <pc:sldMk cId="0" sldId="419"/>
         </pc:sldMkLst>
+        <pc:spChg chg="mod">
+          <ac:chgData name="Todd Lines" userId="afaf7c3a-e8aa-4568-882a-02ad8f9e19b0" providerId="ADAL" clId="{5FF5AC1B-ABA9-43D7-A1E3-2D92732CD6E2}" dt="2026-09-15T19:10:42.235" v="549" actId="1076"/>
+          <ac:spMkLst>
+            <pc:docMk/>
+            <pc:sldMk cId="0" sldId="419"/>
+            <ac:spMk id="20491" creationId="{00000000-0000-0000-0000-000000000000}"/>
+          </ac:spMkLst>
+        </pc:spChg>
+        <pc:spChg chg="mod">
+          <ac:chgData name="Todd Lines" userId="afaf7c3a-e8aa-4568-882a-02ad8f9e19b0" providerId="ADAL" clId="{5FF5AC1B-ABA9-43D7-A1E3-2D92732CD6E2}" dt="2026-09-15T19:10:48.775" v="550" actId="1076"/>
+          <ac:spMkLst>
+            <pc:docMk/>
+            <pc:sldMk cId="0" sldId="419"/>
+            <ac:spMk id="20492" creationId="{00000000-0000-0000-0000-000000000000}"/>
+          </ac:spMkLst>
+        </pc:spChg>
       </pc:sldChg>
-      <pc:sldChg chg="add">
-        <pc:chgData name="Todd Lines" userId="afaf7c3a-e8aa-4568-882a-02ad8f9e19b0" providerId="ADAL" clId="{5FF5AC1B-ABA9-43D7-A1E3-2D92732CD6E2}" dt="2026-08-26T18:18:10.013" v="0"/>
+      <pc:sldChg chg="addSp delSp modSp add mod">
+        <pc:chgData name="Todd Lines" userId="afaf7c3a-e8aa-4568-882a-02ad8f9e19b0" providerId="ADAL" clId="{5FF5AC1B-ABA9-43D7-A1E3-2D92732CD6E2}" dt="2026-09-15T19:10:30.383" v="548" actId="20577"/>
         <pc:sldMkLst>
           <pc:docMk/>
           <pc:sldMk cId="0" sldId="420"/>
         </pc:sldMkLst>
+        <pc:spChg chg="mod">
+          <ac:chgData name="Todd Lines" userId="afaf7c3a-e8aa-4568-882a-02ad8f9e19b0" providerId="ADAL" clId="{5FF5AC1B-ABA9-43D7-A1E3-2D92732CD6E2}" dt="2026-09-15T19:10:30.383" v="548" actId="20577"/>
+          <ac:spMkLst>
+            <pc:docMk/>
+            <pc:sldMk cId="0" sldId="420"/>
+            <ac:spMk id="21508" creationId="{00000000-0000-0000-0000-000000000000}"/>
+          </ac:spMkLst>
+        </pc:spChg>
+        <pc:spChg chg="mod">
+          <ac:chgData name="Todd Lines" userId="afaf7c3a-e8aa-4568-882a-02ad8f9e19b0" providerId="ADAL" clId="{5FF5AC1B-ABA9-43D7-A1E3-2D92732CD6E2}" dt="2026-09-15T19:10:21.357" v="546" actId="20577"/>
+          <ac:spMkLst>
+            <pc:docMk/>
+            <pc:sldMk cId="0" sldId="420"/>
+            <ac:spMk id="21510" creationId="{00000000-0000-0000-0000-000000000000}"/>
+          </ac:spMkLst>
+        </pc:spChg>
+        <pc:picChg chg="add del">
+          <ac:chgData name="Todd Lines" userId="afaf7c3a-e8aa-4568-882a-02ad8f9e19b0" providerId="ADAL" clId="{5FF5AC1B-ABA9-43D7-A1E3-2D92732CD6E2}" dt="2026-09-15T18:46:14.313" v="512" actId="21"/>
+          <ac:picMkLst>
+            <pc:docMk/>
+            <pc:sldMk cId="0" sldId="420"/>
+            <ac:picMk id="5" creationId="{223D0617-182A-EDD4-5603-C087DCFB85A2}"/>
+          </ac:picMkLst>
+        </pc:picChg>
       </pc:sldChg>
       <pc:sldChg chg="add">
         <pc:chgData name="Todd Lines" userId="afaf7c3a-e8aa-4568-882a-02ad8f9e19b0" providerId="ADAL" clId="{5FF5AC1B-ABA9-43D7-A1E3-2D92732CD6E2}" dt="2026-08-26T18:18:10.013" v="0"/>
@@ -517,7 +690,7 @@
           <a:p>
             <a:fld id="{DE8946E1-4BD4-4BDB-BF97-56629F967A47}" type="datetimeFigureOut">
               <a:rPr lang="en-US" smtClean="0"/>
-              <a:t>8/26/2026</a:t>
+              <a:t>9/15/2026</a:t>
             </a:fld>
             <a:endParaRPr lang="en-US"/>
           </a:p>
@@ -715,7 +888,7 @@
           <a:p>
             <a:fld id="{DE8946E1-4BD4-4BDB-BF97-56629F967A47}" type="datetimeFigureOut">
               <a:rPr lang="en-US" smtClean="0"/>
-              <a:t>8/26/2026</a:t>
+              <a:t>9/15/2026</a:t>
             </a:fld>
             <a:endParaRPr lang="en-US"/>
           </a:p>
@@ -923,7 +1096,7 @@
           <a:p>
             <a:fld id="{DE8946E1-4BD4-4BDB-BF97-56629F967A47}" type="datetimeFigureOut">
               <a:rPr lang="en-US" smtClean="0"/>
-              <a:t>8/26/2026</a:t>
+              <a:t>9/15/2026</a:t>
             </a:fld>
             <a:endParaRPr lang="en-US"/>
           </a:p>
@@ -1121,7 +1294,7 @@
           <a:p>
             <a:fld id="{DE8946E1-4BD4-4BDB-BF97-56629F967A47}" type="datetimeFigureOut">
               <a:rPr lang="en-US" smtClean="0"/>
-              <a:t>8/26/2026</a:t>
+              <a:t>9/15/2026</a:t>
             </a:fld>
             <a:endParaRPr lang="en-US"/>
           </a:p>
@@ -1396,7 +1569,7 @@
           <a:p>
             <a:fld id="{DE8946E1-4BD4-4BDB-BF97-56629F967A47}" type="datetimeFigureOut">
               <a:rPr lang="en-US" smtClean="0"/>
-              <a:t>8/26/2026</a:t>
+              <a:t>9/15/2026</a:t>
             </a:fld>
             <a:endParaRPr lang="en-US"/>
           </a:p>
@@ -1661,7 +1834,7 @@
           <a:p>
             <a:fld id="{DE8946E1-4BD4-4BDB-BF97-56629F967A47}" type="datetimeFigureOut">
               <a:rPr lang="en-US" smtClean="0"/>
-              <a:t>8/26/2026</a:t>
+              <a:t>9/15/2026</a:t>
             </a:fld>
             <a:endParaRPr lang="en-US"/>
           </a:p>
@@ -2073,7 +2246,7 @@
           <a:p>
             <a:fld id="{DE8946E1-4BD4-4BDB-BF97-56629F967A47}" type="datetimeFigureOut">
               <a:rPr lang="en-US" smtClean="0"/>
-              <a:t>8/26/2026</a:t>
+              <a:t>9/15/2026</a:t>
             </a:fld>
             <a:endParaRPr lang="en-US"/>
           </a:p>
@@ -2214,7 +2387,7 @@
           <a:p>
             <a:fld id="{DE8946E1-4BD4-4BDB-BF97-56629F967A47}" type="datetimeFigureOut">
               <a:rPr lang="en-US" smtClean="0"/>
-              <a:t>8/26/2026</a:t>
+              <a:t>9/15/2026</a:t>
             </a:fld>
             <a:endParaRPr lang="en-US"/>
           </a:p>
@@ -2327,7 +2500,7 @@
           <a:p>
             <a:fld id="{DE8946E1-4BD4-4BDB-BF97-56629F967A47}" type="datetimeFigureOut">
               <a:rPr lang="en-US" smtClean="0"/>
-              <a:t>8/26/2026</a:t>
+              <a:t>9/15/2026</a:t>
             </a:fld>
             <a:endParaRPr lang="en-US"/>
           </a:p>
@@ -2638,7 +2811,7 @@
           <a:p>
             <a:fld id="{DE8946E1-4BD4-4BDB-BF97-56629F967A47}" type="datetimeFigureOut">
               <a:rPr lang="en-US" smtClean="0"/>
-              <a:t>8/26/2026</a:t>
+              <a:t>9/15/2026</a:t>
             </a:fld>
             <a:endParaRPr lang="en-US"/>
           </a:p>
@@ -2926,7 +3099,7 @@
           <a:p>
             <a:fld id="{DE8946E1-4BD4-4BDB-BF97-56629F967A47}" type="datetimeFigureOut">
               <a:rPr lang="en-US" smtClean="0"/>
-              <a:t>8/26/2026</a:t>
+              <a:t>9/15/2026</a:t>
             </a:fld>
             <a:endParaRPr lang="en-US"/>
           </a:p>
@@ -3167,7 +3340,7 @@
           <a:p>
             <a:fld id="{DE8946E1-4BD4-4BDB-BF97-56629F967A47}" type="datetimeFigureOut">
               <a:rPr lang="en-US" smtClean="0"/>
-              <a:t>8/26/2026</a:t>
+              <a:t>9/15/2026</a:t>
             </a:fld>
             <a:endParaRPr lang="en-US"/>
           </a:p>
@@ -19172,15 +19345,17 @@
           </a:xfrm>
         </p:spPr>
         <p:txBody>
-          <a:bodyPr/>
+          <a:bodyPr>
+            <a:normAutofit lnSpcReduction="10000"/>
+          </a:bodyPr>
           <a:lstStyle/>
           <a:p>
-            <a:pPr marL="609600" indent="-609600">
+            <a:pPr marL="0" indent="0">
               <a:buNone/>
             </a:pPr>
             <a:r>
               <a:rPr lang="en-US" sz="2000" dirty="0"/>
-              <a:t>A circular object is in uniform motion. The drawing is at t = 0. The projection on the x-axis shown will have what amplitude and phase?</a:t>
+              <a:t>A circular object is in uniform motion. The drawing is at t = 0. An old fashioned lightbulb is above the circular object. It shines down on the object while the object turns. There is a knob on the circular object. The shadow of this knob is a projection onto the x-axis. If we consider the motion of the shadow, it will look like an oscillation. What will be the knob shadow’s amplitude and phase?</a:t>
             </a:r>
           </a:p>
           <a:p>
@@ -19247,7 +19422,7 @@
               <a:rPr lang="en-US" sz="2000" dirty="0">
                 <a:sym typeface="Symbol" pitchFamily="18" charset="2"/>
               </a:rPr>
-              <a:t>Can you draw a graph of x vs. t?</a:t>
+              <a:t>Could you draw a graph of x vs. t for the knob shadow?</a:t>
             </a:r>
           </a:p>
         </p:txBody>
@@ -20384,6 +20559,237 @@
           <a:lstStyle/>
           <a:p>
             <a:endParaRPr lang="en-US"/>
+          </a:p>
+        </p:txBody>
+      </p:sp>
+      <p:sp>
+        <p:nvSpPr>
+          <p:cNvPr id="2" name="TextBox 1">
+            <a:extLst>
+              <a:ext uri="{FF2B5EF4-FFF2-40B4-BE49-F238E27FC236}">
+                <a16:creationId xmlns:a16="http://schemas.microsoft.com/office/drawing/2014/main" id="{68B2C6A7-B546-F75E-6AF8-97EA99858679}"/>
+              </a:ext>
+            </a:extLst>
+          </p:cNvPr>
+          <p:cNvSpPr txBox="1"/>
+          <p:nvPr/>
+        </p:nvSpPr>
+        <p:spPr>
+          <a:xfrm>
+            <a:off x="10258426" y="3751937"/>
+            <a:ext cx="1659493" cy="369332"/>
+          </a:xfrm>
+          <a:prstGeom prst="rect">
+            <a:avLst/>
+          </a:prstGeom>
+          <a:noFill/>
+        </p:spPr>
+        <p:txBody>
+          <a:bodyPr wrap="none" rtlCol="0">
+            <a:spAutoFit/>
+          </a:bodyPr>
+          <a:lstStyle/>
+          <a:p>
+            <a:r>
+              <a:rPr lang="en-US" dirty="0"/>
+              <a:t>Circular object</a:t>
+            </a:r>
+          </a:p>
+        </p:txBody>
+      </p:sp>
+      <p:cxnSp>
+        <p:nvCxnSpPr>
+          <p:cNvPr id="6" name="Straight Arrow Connector 5">
+            <a:extLst>
+              <a:ext uri="{FF2B5EF4-FFF2-40B4-BE49-F238E27FC236}">
+                <a16:creationId xmlns:a16="http://schemas.microsoft.com/office/drawing/2014/main" id="{576C3C52-2B8E-31C2-F156-A26981F96AD7}"/>
+              </a:ext>
+            </a:extLst>
+          </p:cNvPr>
+          <p:cNvCxnSpPr>
+            <a:cxnSpLocks/>
+          </p:cNvCxnSpPr>
+          <p:nvPr/>
+        </p:nvCxnSpPr>
+        <p:spPr>
+          <a:xfrm flipH="1">
+            <a:off x="8898820" y="3952477"/>
+            <a:ext cx="1359606" cy="349737"/>
+          </a:xfrm>
+          <a:prstGeom prst="straightConnector1">
+            <a:avLst/>
+          </a:prstGeom>
+          <a:ln>
+            <a:prstDash val="dash"/>
+            <a:tailEnd type="triangle" w="lg" len="lg"/>
+          </a:ln>
+        </p:spPr>
+        <p:style>
+          <a:lnRef idx="2">
+            <a:schemeClr val="accent1"/>
+          </a:lnRef>
+          <a:fillRef idx="0">
+            <a:schemeClr val="accent1"/>
+          </a:fillRef>
+          <a:effectRef idx="1">
+            <a:schemeClr val="accent1"/>
+          </a:effectRef>
+          <a:fontRef idx="minor">
+            <a:schemeClr val="tx1"/>
+          </a:fontRef>
+        </p:style>
+      </p:cxnSp>
+      <p:cxnSp>
+        <p:nvCxnSpPr>
+          <p:cNvPr id="12" name="Straight Arrow Connector 11">
+            <a:extLst>
+              <a:ext uri="{FF2B5EF4-FFF2-40B4-BE49-F238E27FC236}">
+                <a16:creationId xmlns:a16="http://schemas.microsoft.com/office/drawing/2014/main" id="{73DBAD94-36FF-722D-7DD0-982C30701053}"/>
+              </a:ext>
+            </a:extLst>
+          </p:cNvPr>
+          <p:cNvCxnSpPr>
+            <a:cxnSpLocks/>
+          </p:cNvCxnSpPr>
+          <p:nvPr/>
+        </p:nvCxnSpPr>
+        <p:spPr>
+          <a:xfrm flipV="1">
+            <a:off x="6815140" y="5580289"/>
+            <a:ext cx="759617" cy="504907"/>
+          </a:xfrm>
+          <a:prstGeom prst="straightConnector1">
+            <a:avLst/>
+          </a:prstGeom>
+          <a:ln>
+            <a:prstDash val="dash"/>
+            <a:tailEnd type="triangle" w="lg" len="lg"/>
+          </a:ln>
+        </p:spPr>
+        <p:style>
+          <a:lnRef idx="2">
+            <a:schemeClr val="accent1"/>
+          </a:lnRef>
+          <a:fillRef idx="0">
+            <a:schemeClr val="accent1"/>
+          </a:fillRef>
+          <a:effectRef idx="1">
+            <a:schemeClr val="accent1"/>
+          </a:effectRef>
+          <a:fontRef idx="minor">
+            <a:schemeClr val="tx1"/>
+          </a:fontRef>
+        </p:style>
+      </p:cxnSp>
+      <p:sp>
+        <p:nvSpPr>
+          <p:cNvPr id="16" name="TextBox 15">
+            <a:extLst>
+              <a:ext uri="{FF2B5EF4-FFF2-40B4-BE49-F238E27FC236}">
+                <a16:creationId xmlns:a16="http://schemas.microsoft.com/office/drawing/2014/main" id="{352720E6-3973-B8E8-0B50-AA434E120C57}"/>
+              </a:ext>
+            </a:extLst>
+          </p:cNvPr>
+          <p:cNvSpPr txBox="1"/>
+          <p:nvPr/>
+        </p:nvSpPr>
+        <p:spPr>
+          <a:xfrm>
+            <a:off x="6135133" y="6219986"/>
+            <a:ext cx="1528047" cy="369332"/>
+          </a:xfrm>
+          <a:prstGeom prst="rect">
+            <a:avLst/>
+          </a:prstGeom>
+          <a:noFill/>
+        </p:spPr>
+        <p:txBody>
+          <a:bodyPr wrap="none" rtlCol="0">
+            <a:spAutoFit/>
+          </a:bodyPr>
+          <a:lstStyle/>
+          <a:p>
+            <a:r>
+              <a:rPr lang="en-US" dirty="0"/>
+              <a:t>Knob shadow</a:t>
+            </a:r>
+          </a:p>
+        </p:txBody>
+      </p:sp>
+      <p:cxnSp>
+        <p:nvCxnSpPr>
+          <p:cNvPr id="17" name="Straight Arrow Connector 16">
+            <a:extLst>
+              <a:ext uri="{FF2B5EF4-FFF2-40B4-BE49-F238E27FC236}">
+                <a16:creationId xmlns:a16="http://schemas.microsoft.com/office/drawing/2014/main" id="{9D31261C-6FE1-9DFD-C51B-FC887E0FD185}"/>
+              </a:ext>
+            </a:extLst>
+          </p:cNvPr>
+          <p:cNvCxnSpPr>
+            <a:cxnSpLocks/>
+          </p:cNvCxnSpPr>
+          <p:nvPr/>
+        </p:nvCxnSpPr>
+        <p:spPr>
+          <a:xfrm flipH="1" flipV="1">
+            <a:off x="8664575" y="2625726"/>
+            <a:ext cx="808036" cy="322173"/>
+          </a:xfrm>
+          <a:prstGeom prst="straightConnector1">
+            <a:avLst/>
+          </a:prstGeom>
+          <a:ln>
+            <a:prstDash val="dash"/>
+            <a:tailEnd type="triangle" w="lg" len="lg"/>
+          </a:ln>
+        </p:spPr>
+        <p:style>
+          <a:lnRef idx="2">
+            <a:schemeClr val="accent1"/>
+          </a:lnRef>
+          <a:fillRef idx="0">
+            <a:schemeClr val="accent1"/>
+          </a:fillRef>
+          <a:effectRef idx="1">
+            <a:schemeClr val="accent1"/>
+          </a:effectRef>
+          <a:fontRef idx="minor">
+            <a:schemeClr val="tx1"/>
+          </a:fontRef>
+        </p:style>
+      </p:cxnSp>
+      <p:sp>
+        <p:nvSpPr>
+          <p:cNvPr id="21" name="TextBox 20">
+            <a:extLst>
+              <a:ext uri="{FF2B5EF4-FFF2-40B4-BE49-F238E27FC236}">
+                <a16:creationId xmlns:a16="http://schemas.microsoft.com/office/drawing/2014/main" id="{1A7E0BC6-3682-A6B5-FD35-D7F4AB9BB1BB}"/>
+              </a:ext>
+            </a:extLst>
+          </p:cNvPr>
+          <p:cNvSpPr txBox="1"/>
+          <p:nvPr/>
+        </p:nvSpPr>
+        <p:spPr>
+          <a:xfrm>
+            <a:off x="9578623" y="2770347"/>
+            <a:ext cx="1162498" cy="369332"/>
+          </a:xfrm>
+          <a:prstGeom prst="rect">
+            <a:avLst/>
+          </a:prstGeom>
+          <a:noFill/>
+        </p:spPr>
+        <p:txBody>
+          <a:bodyPr wrap="none" rtlCol="0">
+            <a:spAutoFit/>
+          </a:bodyPr>
+          <a:lstStyle/>
+          <a:p>
+            <a:r>
+              <a:rPr lang="en-US" dirty="0"/>
+              <a:t>Light bulb</a:t>
+            </a:r>
           </a:p>
         </p:txBody>
       </p:sp>
@@ -34054,56 +34460,6 @@
           </a:graphicData>
         </a:graphic>
       </p:graphicFrame>
-      <p:sp>
-        <p:nvSpPr>
-          <p:cNvPr id="14344" name="Rectangle 7"/>
-          <p:cNvSpPr>
-            <a:spLocks noChangeArrowheads="1"/>
-          </p:cNvSpPr>
-          <p:nvPr/>
-        </p:nvSpPr>
-        <p:spPr bwMode="auto">
-          <a:xfrm>
-            <a:off x="1524001" y="2510909"/>
-            <a:ext cx="184731" cy="369332"/>
-          </a:xfrm>
-          <a:prstGeom prst="rect">
-            <a:avLst/>
-          </a:prstGeom>
-          <a:noFill/>
-          <a:ln>
-            <a:noFill/>
-          </a:ln>
-          <a:extLst>
-            <a:ext uri="{909E8E84-426E-40DD-AFC4-6F175D3DCCD1}">
-              <a14:hiddenFill xmlns:a14="http://schemas.microsoft.com/office/drawing/2010/main">
-                <a:solidFill>
-                  <a:srgbClr val="FFFFFF"/>
-                </a:solidFill>
-              </a14:hiddenFill>
-            </a:ext>
-            <a:ext uri="{91240B29-F687-4F45-9708-019B960494DF}">
-              <a14:hiddenLine xmlns:a14="http://schemas.microsoft.com/office/drawing/2010/main" w="9525" algn="ctr">
-                <a:solidFill>
-                  <a:srgbClr val="000000"/>
-                </a:solidFill>
-                <a:miter lim="800000"/>
-                <a:headEnd/>
-                <a:tailEnd/>
-              </a14:hiddenLine>
-            </a:ext>
-          </a:extLst>
-        </p:spPr>
-        <p:txBody>
-          <a:bodyPr wrap="none" anchor="ctr">
-            <a:spAutoFit/>
-          </a:bodyPr>
-          <a:lstStyle/>
-          <a:p>
-            <a:endParaRPr lang="en-US"/>
-          </a:p>
-        </p:txBody>
-      </p:sp>
       <p:pic>
         <p:nvPicPr>
           <p:cNvPr id="14348" name="Picture 12"/>
@@ -38266,8 +38622,8 @@
           </a:p>
         </p:txBody>
       </p:sp>
-      <mc:AlternateContent xmlns:mc="http://schemas.openxmlformats.org/markup-compatibility/2006">
-        <mc:Choice xmlns:a14="http://schemas.microsoft.com/office/drawing/2010/main" Requires="a14">
+      <mc:AlternateContent xmlns:mc="http://schemas.openxmlformats.org/markup-compatibility/2006" xmlns:a14="http://schemas.microsoft.com/office/drawing/2010/main">
+        <mc:Choice Requires="a14">
           <p:sp>
             <p:nvSpPr>
               <p:cNvPr id="20488" name="Object 7"/>
@@ -38671,7 +39027,7 @@
             </p:txBody>
           </p:sp>
         </mc:Choice>
-        <mc:Fallback>
+        <mc:Fallback xmlns="">
           <p:sp>
             <p:nvSpPr>
               <p:cNvPr id="20488" name="Object 7"/>
@@ -38763,8 +39119,8 @@
           </a:p>
         </p:txBody>
       </p:sp>
-      <mc:AlternateContent xmlns:mc="http://schemas.openxmlformats.org/markup-compatibility/2006">
-        <mc:Choice xmlns:a14="http://schemas.microsoft.com/office/drawing/2010/main" Requires="a14">
+      <mc:AlternateContent xmlns:mc="http://schemas.openxmlformats.org/markup-compatibility/2006" xmlns:a14="http://schemas.microsoft.com/office/drawing/2010/main">
+        <mc:Choice Requires="a14">
           <p:sp>
             <p:nvSpPr>
               <p:cNvPr id="20490" name="Object 9"/>
@@ -38898,7 +39254,7 @@
             </p:txBody>
           </p:sp>
         </mc:Choice>
-        <mc:Fallback>
+        <mc:Fallback xmlns="">
           <p:sp>
             <p:nvSpPr>
               <p:cNvPr id="20490" name="Object 9"/>
@@ -38950,7 +39306,7 @@
             </p:nvSpPr>
             <p:spPr bwMode="auto">
               <a:xfrm>
-                <a:off x="5641977" y="5621868"/>
+                <a:off x="7981416" y="5392561"/>
                 <a:ext cx="2655357" cy="1146351"/>
               </a:xfrm>
               <a:prstGeom prst="rect">
@@ -39320,7 +39676,7 @@
             </p:nvSpPr>
             <p:spPr bwMode="auto">
               <a:xfrm>
-                <a:off x="5641977" y="5621868"/>
+                <a:off x="7981416" y="5392561"/>
                 <a:ext cx="2655357" cy="1146351"/>
               </a:xfrm>
               <a:prstGeom prst="rect">
@@ -39361,7 +39717,7 @@
             </p:nvSpPr>
             <p:spPr bwMode="auto">
               <a:xfrm>
-                <a:off x="2540001" y="5772151"/>
+                <a:off x="5383476" y="6162930"/>
                 <a:ext cx="2912532" cy="654050"/>
               </a:xfrm>
               <a:prstGeom prst="rect">
@@ -39532,7 +39888,7 @@
             </p:nvSpPr>
             <p:spPr bwMode="auto">
               <a:xfrm>
-                <a:off x="2540001" y="5772151"/>
+                <a:off x="5383476" y="6162930"/>
                 <a:ext cx="2912532" cy="654050"/>
               </a:xfrm>
               <a:prstGeom prst="rect">
@@ -39777,23 +40133,23 @@
           <a:p>
             <a:pPr eaLnBrk="1" hangingPunct="1"/>
             <a:r>
-              <a:rPr lang="en-US" sz="1800"/>
+              <a:rPr lang="en-US" sz="1800" dirty="0"/>
               <a:t>Notice that right at  </a:t>
             </a:r>
             <a:r>
-              <a:rPr lang="en-US" sz="1800">
+              <a:rPr lang="en-US" sz="1800" dirty="0">
                 <a:sym typeface="Symbol" pitchFamily="18" charset="2"/>
               </a:rPr>
               <a:t></a:t>
             </a:r>
             <a:r>
-              <a:rPr lang="en-US" sz="1800" baseline="-25000">
+              <a:rPr lang="en-US" sz="1800" baseline="-25000" dirty="0">
                 <a:sym typeface="Symbol" pitchFamily="18" charset="2"/>
               </a:rPr>
-              <a:t>o</a:t>
+              <a:t>f</a:t>
             </a:r>
             <a:r>
-              <a:rPr lang="en-US" sz="1800"/>
+              <a:rPr lang="en-US" sz="1800" dirty="0"/>
               <a:t> our solution gets very big </a:t>
             </a:r>
           </a:p>
@@ -39884,7 +40240,7 @@
                     </m:oMathParaPr>
                     <m:oMath>
                       <m:r>
-                        <a:rPr lang="en-US" i="1">
+                        <a:rPr lang="en-US" i="1" smtClean="0">
                           <a:solidFill>
                             <a:srgbClr val="000000"/>
                           </a:solidFill>
@@ -39893,7 +40249,7 @@
                         <m:t>𝐴</m:t>
                       </m:r>
                       <m:r>
-                        <a:rPr lang="en-US" i="1">
+                        <a:rPr lang="en-US" i="1" smtClean="0">
                           <a:solidFill>
                             <a:srgbClr val="000000"/>
                           </a:solidFill>
@@ -40003,7 +40359,7 @@
                                   <m:d>
                                     <m:dPr>
                                       <m:ctrlPr>
-                                        <a:rPr lang="en-US" i="1">
+                                        <a:rPr lang="en-US" i="1" smtClean="0">
                                           <a:solidFill>
                                             <a:srgbClr val="000000"/>
                                           </a:solidFill>
@@ -40012,31 +40368,44 @@
                                       </m:ctrlPr>
                                     </m:dPr>
                                     <m:e>
-                                      <m:sSup>
-                                        <m:sSupPr>
+                                      <m:sSubSup>
+                                        <m:sSubSupPr>
                                           <m:ctrlPr>
-                                            <a:rPr lang="en-US" i="1">
+                                            <a:rPr lang="en-US" i="1" smtClean="0">
+                                              <a:solidFill>
+                                                <a:srgbClr val="000000"/>
+                                              </a:solidFill>
+                                              <a:latin typeface="Cambria Math" panose="02040503050406030204" pitchFamily="18" charset="0"/>
+                                              <a:ea typeface="Cambria Math" panose="02040503050406030204" pitchFamily="18" charset="0"/>
+                                            </a:rPr>
+                                          </m:ctrlPr>
+                                        </m:sSubSupPr>
+                                        <m:e>
+                                          <m:r>
+                                            <a:rPr lang="en-US" i="1" smtClean="0">
+                                              <a:solidFill>
+                                                <a:srgbClr val="000000"/>
+                                              </a:solidFill>
+                                              <a:latin typeface="Cambria Math" panose="02040503050406030204" pitchFamily="18" charset="0"/>
+                                              <a:ea typeface="Cambria Math" panose="02040503050406030204" pitchFamily="18" charset="0"/>
+                                            </a:rPr>
+                                            <m:t>𝜔</m:t>
+                                          </m:r>
+                                        </m:e>
+                                        <m:sub>
+                                          <m:r>
+                                            <a:rPr lang="en-US" b="0" i="1" smtClean="0">
                                               <a:solidFill>
                                                 <a:srgbClr val="000000"/>
                                               </a:solidFill>
                                               <a:latin typeface="Cambria Math" panose="02040503050406030204" pitchFamily="18" charset="0"/>
                                             </a:rPr>
-                                          </m:ctrlPr>
-                                        </m:sSupPr>
-                                        <m:e>
-                                          <m:r>
-                                            <a:rPr lang="en-US" i="1">
-                                              <a:solidFill>
-                                                <a:srgbClr val="000000"/>
-                                              </a:solidFill>
-                                              <a:latin typeface="Cambria Math" panose="02040503050406030204" pitchFamily="18" charset="0"/>
-                                            </a:rPr>
-                                            <m:t>𝜔</m:t>
+                                            <m:t>𝑓</m:t>
                                           </m:r>
-                                        </m:e>
+                                        </m:sub>
                                         <m:sup>
                                           <m:r>
-                                            <a:rPr lang="en-US" i="1">
+                                            <a:rPr lang="en-US" b="0" i="1" smtClean="0">
                                               <a:solidFill>
                                                 <a:srgbClr val="000000"/>
                                               </a:solidFill>
@@ -40045,7 +40414,7 @@
                                             <m:t>2</m:t>
                                           </m:r>
                                         </m:sup>
-                                      </m:sSup>
+                                      </m:sSubSup>
                                       <m:r>
                                         <a:rPr lang="en-US" i="1">
                                           <a:solidFill>
@@ -40058,28 +40427,30 @@
                                       <m:sSubSup>
                                         <m:sSubSupPr>
                                           <m:ctrlPr>
-                                            <a:rPr lang="en-US" i="1">
+                                            <a:rPr lang="en-US" i="1" smtClean="0">
                                               <a:solidFill>
                                                 <a:srgbClr val="000000"/>
                                               </a:solidFill>
                                               <a:latin typeface="Cambria Math" panose="02040503050406030204" pitchFamily="18" charset="0"/>
+                                              <a:ea typeface="Cambria Math" panose="02040503050406030204" pitchFamily="18" charset="0"/>
                                             </a:rPr>
                                           </m:ctrlPr>
                                         </m:sSubSupPr>
                                         <m:e>
                                           <m:r>
-                                            <a:rPr lang="en-US" i="1">
+                                            <a:rPr lang="en-US" i="1" smtClean="0">
                                               <a:solidFill>
                                                 <a:srgbClr val="000000"/>
                                               </a:solidFill>
                                               <a:latin typeface="Cambria Math" panose="02040503050406030204" pitchFamily="18" charset="0"/>
+                                              <a:ea typeface="Cambria Math" panose="02040503050406030204" pitchFamily="18" charset="0"/>
                                             </a:rPr>
                                             <m:t>𝜔</m:t>
                                           </m:r>
                                         </m:e>
                                         <m:sub>
                                           <m:r>
-                                            <a:rPr lang="en-US" i="1">
+                                            <a:rPr lang="en-US" b="0" i="1" smtClean="0">
                                               <a:solidFill>
                                                 <a:srgbClr val="000000"/>
                                               </a:solidFill>
@@ -40090,7 +40461,7 @@
                                         </m:sub>
                                         <m:sup>
                                           <m:r>
-                                            <a:rPr lang="en-US" i="1">
+                                            <a:rPr lang="en-US" b="0" i="1" smtClean="0">
                                               <a:solidFill>
                                                 <a:srgbClr val="000000"/>
                                               </a:solidFill>
@@ -40169,15 +40540,42 @@
                                             </a:rPr>
                                             <m:t>𝑏</m:t>
                                           </m:r>
-                                          <m:r>
-                                            <a:rPr lang="en-US" i="1">
-                                              <a:solidFill>
-                                                <a:srgbClr val="000000"/>
-                                              </a:solidFill>
-                                              <a:latin typeface="Cambria Math" panose="02040503050406030204" pitchFamily="18" charset="0"/>
-                                            </a:rPr>
-                                            <m:t>𝜔</m:t>
-                                          </m:r>
+                                          <m:sSub>
+                                            <m:sSubPr>
+                                              <m:ctrlPr>
+                                                <a:rPr lang="en-US" i="1" smtClean="0">
+                                                  <a:solidFill>
+                                                    <a:srgbClr val="000000"/>
+                                                  </a:solidFill>
+                                                  <a:latin typeface="Cambria Math" panose="02040503050406030204" pitchFamily="18" charset="0"/>
+                                                  <a:ea typeface="Cambria Math" panose="02040503050406030204" pitchFamily="18" charset="0"/>
+                                                </a:rPr>
+                                              </m:ctrlPr>
+                                            </m:sSubPr>
+                                            <m:e>
+                                              <m:r>
+                                                <a:rPr lang="en-US" i="1" smtClean="0">
+                                                  <a:solidFill>
+                                                    <a:srgbClr val="000000"/>
+                                                  </a:solidFill>
+                                                  <a:latin typeface="Cambria Math" panose="02040503050406030204" pitchFamily="18" charset="0"/>
+                                                  <a:ea typeface="Cambria Math" panose="02040503050406030204" pitchFamily="18" charset="0"/>
+                                                </a:rPr>
+                                                <m:t>𝜔</m:t>
+                                              </m:r>
+                                            </m:e>
+                                            <m:sub>
+                                              <m:r>
+                                                <a:rPr lang="en-US" b="0" i="1" smtClean="0">
+                                                  <a:solidFill>
+                                                    <a:srgbClr val="000000"/>
+                                                  </a:solidFill>
+                                                  <a:latin typeface="Cambria Math" panose="02040503050406030204" pitchFamily="18" charset="0"/>
+                                                </a:rPr>
+                                                <m:t>𝑓</m:t>
+                                              </m:r>
+                                            </m:sub>
+                                          </m:sSub>
                                         </m:num>
                                         <m:den>
                                           <m:r>
@@ -40454,8 +40852,8 @@
           </a:prstGeom>
         </p:spPr>
       </p:pic>
-      <mc:AlternateContent xmlns:mc="http://schemas.openxmlformats.org/markup-compatibility/2006">
-        <mc:Choice xmlns:a14="http://schemas.microsoft.com/office/drawing/2010/main" Requires="a14">
+      <mc:AlternateContent xmlns:mc="http://schemas.openxmlformats.org/markup-compatibility/2006" xmlns:a14="http://schemas.microsoft.com/office/drawing/2010/main">
+        <mc:Choice Requires="a14">
           <p:sp>
             <p:nvSpPr>
               <p:cNvPr id="4" name="TextBox 3">
@@ -40503,7 +40901,7 @@
             </p:txBody>
           </p:sp>
         </mc:Choice>
-        <mc:Fallback>
+        <mc:Fallback xmlns="">
           <p:sp>
             <p:nvSpPr>
               <p:cNvPr id="4" name="TextBox 3">
@@ -40972,8 +41370,8 @@
           </a:p>
         </p:txBody>
       </p:sp>
-      <mc:AlternateContent xmlns:mc="http://schemas.openxmlformats.org/markup-compatibility/2006">
-        <mc:Choice xmlns:a14="http://schemas.microsoft.com/office/drawing/2010/main" Requires="a14">
+      <mc:AlternateContent xmlns:mc="http://schemas.openxmlformats.org/markup-compatibility/2006" xmlns:a14="http://schemas.microsoft.com/office/drawing/2010/main">
+        <mc:Choice Requires="a14">
           <p:sp>
             <p:nvSpPr>
               <p:cNvPr id="22536" name="Object 7"/>
@@ -41149,7 +41547,7 @@
             </p:txBody>
           </p:sp>
         </mc:Choice>
-        <mc:Fallback>
+        <mc:Fallback xmlns="">
           <p:sp>
             <p:nvSpPr>
               <p:cNvPr id="22536" name="Object 7"/>
@@ -41952,8 +42350,8 @@
           </a:p>
         </p:txBody>
       </p:sp>
-      <mc:AlternateContent xmlns:mc="http://schemas.openxmlformats.org/markup-compatibility/2006">
-        <mc:Choice xmlns:a14="http://schemas.microsoft.com/office/drawing/2010/main" Requires="a14">
+      <mc:AlternateContent xmlns:mc="http://schemas.openxmlformats.org/markup-compatibility/2006" xmlns:a14="http://schemas.microsoft.com/office/drawing/2010/main">
+        <mc:Choice Requires="a14">
           <p:sp>
             <p:nvSpPr>
               <p:cNvPr id="6" name="TextBox 5">
@@ -42001,7 +42399,7 @@
             </p:txBody>
           </p:sp>
         </mc:Choice>
-        <mc:Fallback>
+        <mc:Fallback xmlns="">
           <p:sp>
             <p:nvSpPr>
               <p:cNvPr id="6" name="TextBox 5">
@@ -45199,8 +45597,8 @@
           </a:graphicData>
         </a:graphic>
       </p:graphicFrame>
-      <mc:AlternateContent xmlns:mc="http://schemas.openxmlformats.org/markup-compatibility/2006">
-        <mc:Choice xmlns:a14="http://schemas.microsoft.com/office/drawing/2010/main" Requires="a14">
+      <mc:AlternateContent xmlns:mc="http://schemas.openxmlformats.org/markup-compatibility/2006" xmlns:a14="http://schemas.microsoft.com/office/drawing/2010/main">
+        <mc:Choice Requires="a14">
           <p:sp>
             <p:nvSpPr>
               <p:cNvPr id="24597" name="Object 20"/>
@@ -45425,7 +45823,7 @@
             </p:txBody>
           </p:sp>
         </mc:Choice>
-        <mc:Fallback>
+        <mc:Fallback xmlns="">
           <p:sp>
             <p:nvSpPr>
               <p:cNvPr id="24597" name="Object 20"/>
@@ -45467,8 +45865,8 @@
           </p:sp>
         </mc:Fallback>
       </mc:AlternateContent>
-      <mc:AlternateContent xmlns:mc="http://schemas.openxmlformats.org/markup-compatibility/2006">
-        <mc:Choice xmlns:a14="http://schemas.microsoft.com/office/drawing/2010/main" Requires="a14">
+      <mc:AlternateContent xmlns:mc="http://schemas.openxmlformats.org/markup-compatibility/2006" xmlns:a14="http://schemas.microsoft.com/office/drawing/2010/main">
+        <mc:Choice Requires="a14">
           <p:sp>
             <p:nvSpPr>
               <p:cNvPr id="24598" name="Object 21"/>
@@ -45602,7 +46000,7 @@
             </p:txBody>
           </p:sp>
         </mc:Choice>
-        <mc:Fallback>
+        <mc:Fallback xmlns="">
           <p:sp>
             <p:nvSpPr>
               <p:cNvPr id="24598" name="Object 21"/>
@@ -45644,8 +46042,8 @@
           </p:sp>
         </mc:Fallback>
       </mc:AlternateContent>
-      <mc:AlternateContent xmlns:mc="http://schemas.openxmlformats.org/markup-compatibility/2006">
-        <mc:Choice xmlns:a14="http://schemas.microsoft.com/office/drawing/2010/main" Requires="a14">
+      <mc:AlternateContent xmlns:mc="http://schemas.openxmlformats.org/markup-compatibility/2006" xmlns:a14="http://schemas.microsoft.com/office/drawing/2010/main">
+        <mc:Choice Requires="a14">
           <p:sp>
             <p:nvSpPr>
               <p:cNvPr id="24599" name="Object 22"/>
@@ -45772,7 +46170,7 @@
             </p:txBody>
           </p:sp>
         </mc:Choice>
-        <mc:Fallback>
+        <mc:Fallback xmlns="">
           <p:sp>
             <p:nvSpPr>
               <p:cNvPr id="24599" name="Object 22"/>
@@ -45814,8 +46212,8 @@
           </p:sp>
         </mc:Fallback>
       </mc:AlternateContent>
-      <mc:AlternateContent xmlns:mc="http://schemas.openxmlformats.org/markup-compatibility/2006">
-        <mc:Choice xmlns:a14="http://schemas.microsoft.com/office/drawing/2010/main" Requires="a14">
+      <mc:AlternateContent xmlns:mc="http://schemas.openxmlformats.org/markup-compatibility/2006" xmlns:a14="http://schemas.microsoft.com/office/drawing/2010/main">
+        <mc:Choice Requires="a14">
           <p:sp>
             <p:nvSpPr>
               <p:cNvPr id="24600" name="Object 23"/>
@@ -46016,7 +46414,7 @@
             </p:txBody>
           </p:sp>
         </mc:Choice>
-        <mc:Fallback>
+        <mc:Fallback xmlns="">
           <p:sp>
             <p:nvSpPr>
               <p:cNvPr id="24600" name="Object 23"/>
@@ -46058,8 +46456,8 @@
           </p:sp>
         </mc:Fallback>
       </mc:AlternateContent>
-      <mc:AlternateContent xmlns:mc="http://schemas.openxmlformats.org/markup-compatibility/2006">
-        <mc:Choice xmlns:a14="http://schemas.microsoft.com/office/drawing/2010/main" Requires="a14">
+      <mc:AlternateContent xmlns:mc="http://schemas.openxmlformats.org/markup-compatibility/2006" xmlns:a14="http://schemas.microsoft.com/office/drawing/2010/main">
+        <mc:Choice Requires="a14">
           <p:sp>
             <p:nvSpPr>
               <p:cNvPr id="24601" name="Object 24"/>
@@ -46427,7 +46825,7 @@
             </p:txBody>
           </p:sp>
         </mc:Choice>
-        <mc:Fallback>
+        <mc:Fallback xmlns="">
           <p:sp>
             <p:nvSpPr>
               <p:cNvPr id="24601" name="Object 24"/>

</xml_diff>